<commit_message>
new chart for UTP!
</commit_message>
<xml_diff>
--- a/assets/template_utp_alumnos.pptx
+++ b/assets/template_utp_alumnos.pptx
@@ -288,7 +288,7 @@
 <file path=ppt/revisionInfo.xml><?xml version="1.0" encoding="utf-8"?>
 <p1510:revInfo xmlns:a="http://schemas.openxmlformats.org/drawingml/2006/main" xmlns:r="http://schemas.openxmlformats.org/officeDocument/2006/relationships" xmlns:p1510="http://schemas.microsoft.com/office/powerpoint/2015/10/main">
   <p1510:revLst>
-    <p1510:client id="{B88747C2-82D1-4EF1-B2BE-7360204C626C}" v="1" dt="2026-04-29T19:05:27.229"/>
+    <p1510:client id="{B88747C2-82D1-4EF1-B2BE-7360204C626C}" v="6" dt="2026-04-29T20:44:33.041"/>
   </p1510:revLst>
 </p1510:revInfo>
 </file>
@@ -297,19 +297,42 @@
 <pc:chgInfo xmlns:a="http://schemas.openxmlformats.org/drawingml/2006/main" xmlns:r="http://schemas.openxmlformats.org/officeDocument/2006/relationships" xmlns:ac="http://schemas.microsoft.com/office/drawing/2013/main/command" xmlns:pc="http://schemas.microsoft.com/office/powerpoint/2013/main/command">
   <pc:docChgLst>
     <pc:chgData name="juani vila bach" userId="140d79d91c36b714" providerId="LiveId" clId="{681BBBA0-CB6B-4408-8383-25A2ECA50787}"/>
-    <pc:docChg chg="custSel modSld">
-      <pc:chgData name="juani vila bach" userId="140d79d91c36b714" providerId="LiveId" clId="{681BBBA0-CB6B-4408-8383-25A2ECA50787}" dt="2026-04-29T19:05:38.398" v="22" actId="20577"/>
+    <pc:docChg chg="undo custSel modSld">
+      <pc:chgData name="juani vila bach" userId="140d79d91c36b714" providerId="LiveId" clId="{681BBBA0-CB6B-4408-8383-25A2ECA50787}" dt="2026-04-29T20:45:29.205" v="60" actId="120"/>
       <pc:docMkLst>
         <pc:docMk/>
       </pc:docMkLst>
+      <pc:sldChg chg="modSp mod">
+        <pc:chgData name="juani vila bach" userId="140d79d91c36b714" providerId="LiveId" clId="{681BBBA0-CB6B-4408-8383-25A2ECA50787}" dt="2026-04-29T20:41:50.291" v="23" actId="2711"/>
+        <pc:sldMkLst>
+          <pc:docMk/>
+          <pc:sldMk cId="0" sldId="258"/>
+        </pc:sldMkLst>
+        <pc:spChg chg="mod">
+          <ac:chgData name="juani vila bach" userId="140d79d91c36b714" providerId="LiveId" clId="{681BBBA0-CB6B-4408-8383-25A2ECA50787}" dt="2026-04-29T20:41:50.291" v="23" actId="2711"/>
+          <ac:spMkLst>
+            <pc:docMk/>
+            <pc:sldMk cId="0" sldId="258"/>
+            <ac:spMk id="64" creationId="{00000000-0000-0000-0000-000000000000}"/>
+          </ac:spMkLst>
+        </pc:spChg>
+        <pc:spChg chg="mod">
+          <ac:chgData name="juani vila bach" userId="140d79d91c36b714" providerId="LiveId" clId="{681BBBA0-CB6B-4408-8383-25A2ECA50787}" dt="2026-04-29T20:41:50.291" v="23" actId="2711"/>
+          <ac:spMkLst>
+            <pc:docMk/>
+            <pc:sldMk cId="0" sldId="258"/>
+            <ac:spMk id="65" creationId="{00000000-0000-0000-0000-000000000000}"/>
+          </ac:spMkLst>
+        </pc:spChg>
+      </pc:sldChg>
       <pc:sldChg chg="addSp delSp modSp mod">
-        <pc:chgData name="juani vila bach" userId="140d79d91c36b714" providerId="LiveId" clId="{681BBBA0-CB6B-4408-8383-25A2ECA50787}" dt="2026-04-29T19:05:38.398" v="22" actId="20577"/>
+        <pc:chgData name="juani vila bach" userId="140d79d91c36b714" providerId="LiveId" clId="{681BBBA0-CB6B-4408-8383-25A2ECA50787}" dt="2026-04-29T20:42:08.448" v="28" actId="1036"/>
         <pc:sldMkLst>
           <pc:docMk/>
           <pc:sldMk cId="0" sldId="259"/>
         </pc:sldMkLst>
         <pc:spChg chg="add mod">
-          <ac:chgData name="juani vila bach" userId="140d79d91c36b714" providerId="LiveId" clId="{681BBBA0-CB6B-4408-8383-25A2ECA50787}" dt="2026-04-29T19:05:31.540" v="8" actId="20577"/>
+          <ac:chgData name="juani vila bach" userId="140d79d91c36b714" providerId="LiveId" clId="{681BBBA0-CB6B-4408-8383-25A2ECA50787}" dt="2026-04-29T20:42:08.448" v="28" actId="1036"/>
           <ac:spMkLst>
             <pc:docMk/>
             <pc:sldMk cId="0" sldId="259"/>
@@ -325,7 +348,7 @@
           </ac:spMkLst>
         </pc:spChg>
         <pc:spChg chg="add mod">
-          <ac:chgData name="juani vila bach" userId="140d79d91c36b714" providerId="LiveId" clId="{681BBBA0-CB6B-4408-8383-25A2ECA50787}" dt="2026-04-29T19:05:35.478" v="15" actId="20577"/>
+          <ac:chgData name="juani vila bach" userId="140d79d91c36b714" providerId="LiveId" clId="{681BBBA0-CB6B-4408-8383-25A2ECA50787}" dt="2026-04-29T20:42:08.448" v="28" actId="1036"/>
           <ac:spMkLst>
             <pc:docMk/>
             <pc:sldMk cId="0" sldId="259"/>
@@ -341,7 +364,7 @@
           </ac:spMkLst>
         </pc:spChg>
         <pc:spChg chg="add mod">
-          <ac:chgData name="juani vila bach" userId="140d79d91c36b714" providerId="LiveId" clId="{681BBBA0-CB6B-4408-8383-25A2ECA50787}" dt="2026-04-29T19:05:38.398" v="22" actId="20577"/>
+          <ac:chgData name="juani vila bach" userId="140d79d91c36b714" providerId="LiveId" clId="{681BBBA0-CB6B-4408-8383-25A2ECA50787}" dt="2026-04-29T20:42:08.448" v="28" actId="1036"/>
           <ac:spMkLst>
             <pc:docMk/>
             <pc:sldMk cId="0" sldId="259"/>
@@ -402,6 +425,29 @@
             <pc:docMk/>
             <pc:sldMk cId="0" sldId="259"/>
             <ac:spMk id="76" creationId="{00000000-0000-0000-0000-000000000000}"/>
+          </ac:spMkLst>
+        </pc:spChg>
+      </pc:sldChg>
+      <pc:sldChg chg="addSp delSp modSp mod">
+        <pc:chgData name="juani vila bach" userId="140d79d91c36b714" providerId="LiveId" clId="{681BBBA0-CB6B-4408-8383-25A2ECA50787}" dt="2026-04-29T20:45:29.205" v="60" actId="120"/>
+        <pc:sldMkLst>
+          <pc:docMk/>
+          <pc:sldMk cId="0" sldId="260"/>
+        </pc:sldMkLst>
+        <pc:spChg chg="add del mod">
+          <ac:chgData name="juani vila bach" userId="140d79d91c36b714" providerId="LiveId" clId="{681BBBA0-CB6B-4408-8383-25A2ECA50787}" dt="2026-04-29T20:43:09.289" v="39" actId="478"/>
+          <ac:spMkLst>
+            <pc:docMk/>
+            <pc:sldMk cId="0" sldId="260"/>
+            <ac:spMk id="2" creationId="{BD6AED9D-657A-0B87-F240-6ACC1E86BFB6}"/>
+          </ac:spMkLst>
+        </pc:spChg>
+        <pc:spChg chg="mod">
+          <ac:chgData name="juani vila bach" userId="140d79d91c36b714" providerId="LiveId" clId="{681BBBA0-CB6B-4408-8383-25A2ECA50787}" dt="2026-04-29T20:45:29.205" v="60" actId="120"/>
+          <ac:spMkLst>
+            <pc:docMk/>
+            <pc:sldMk cId="0" sldId="260"/>
+            <ac:spMk id="81" creationId="{00000000-0000-0000-0000-000000000000}"/>
           </ac:spMkLst>
         </pc:spChg>
       </pc:sldChg>
@@ -6745,7 +6791,7 @@
                 <a:solidFill>
                   <a:schemeClr val="lt1"/>
                 </a:solidFill>
-                <a:latin typeface="TT Squares Black" panose="02000505040000020003" pitchFamily="50" charset="0"/>
+                <a:latin typeface="Formular" panose="02000000000000000000" pitchFamily="2" charset="0"/>
                 <a:ea typeface="Public Sans"/>
                 <a:cs typeface="Public Sans"/>
                 <a:sym typeface="Public Sans"/>
@@ -6756,7 +6802,7 @@
               <a:solidFill>
                 <a:schemeClr val="lt1"/>
               </a:solidFill>
-              <a:latin typeface="TT Squares Black" panose="02000505040000020003" pitchFamily="50" charset="0"/>
+              <a:latin typeface="Formular" panose="02000000000000000000" pitchFamily="2" charset="0"/>
               <a:ea typeface="Public Sans"/>
               <a:cs typeface="Public Sans"/>
               <a:sym typeface="Public Sans"/>
@@ -6808,7 +6854,7 @@
                 <a:solidFill>
                   <a:schemeClr val="lt1"/>
                 </a:solidFill>
-                <a:latin typeface="TT Squares Black" panose="02000505040000020003" pitchFamily="50" charset="0"/>
+                <a:latin typeface="Formular" panose="02000000000000000000" pitchFamily="2" charset="0"/>
                 <a:ea typeface="Public Sans"/>
                 <a:cs typeface="Public Sans"/>
                 <a:sym typeface="Public Sans"/>
@@ -6819,7 +6865,7 @@
               <a:solidFill>
                 <a:schemeClr val="lt1"/>
               </a:solidFill>
-              <a:latin typeface="TT Squares Black" panose="02000505040000020003" pitchFamily="50" charset="0"/>
+              <a:latin typeface="Formular" panose="02000000000000000000" pitchFamily="2" charset="0"/>
               <a:ea typeface="Public Sans"/>
               <a:cs typeface="Public Sans"/>
               <a:sym typeface="Public Sans"/>
@@ -6839,7 +6885,7 @@
               <a:solidFill>
                 <a:schemeClr val="lt1"/>
               </a:solidFill>
-              <a:latin typeface="TT Squares Black" panose="02000505040000020003" pitchFamily="50" charset="0"/>
+              <a:latin typeface="Formular" panose="02000000000000000000" pitchFamily="2" charset="0"/>
               <a:ea typeface="Public Sans"/>
               <a:cs typeface="Public Sans"/>
               <a:sym typeface="Public Sans"/>
@@ -6948,7 +6994,7 @@
         </p:nvSpPr>
         <p:spPr>
           <a:xfrm>
-            <a:off x="1450475" y="9505349"/>
+            <a:off x="1450475" y="9424667"/>
             <a:ext cx="7357200" cy="1597200"/>
           </a:xfrm>
           <a:prstGeom prst="rect">
@@ -7153,7 +7199,7 @@
         </p:nvSpPr>
         <p:spPr>
           <a:xfrm>
-            <a:off x="1450475" y="12245287"/>
+            <a:off x="1450475" y="12164605"/>
             <a:ext cx="7357200" cy="1597200"/>
           </a:xfrm>
           <a:prstGeom prst="rect">
@@ -7358,7 +7404,7 @@
         </p:nvSpPr>
         <p:spPr>
           <a:xfrm>
-            <a:off x="1450475" y="15287823"/>
+            <a:off x="1450475" y="15207141"/>
             <a:ext cx="7357200" cy="1597200"/>
           </a:xfrm>
           <a:prstGeom prst="rect">
@@ -7595,8 +7641,8 @@
         </p:nvSpPr>
         <p:spPr>
           <a:xfrm>
-            <a:off x="1450475" y="10626625"/>
-            <a:ext cx="7184700" cy="5258100"/>
+            <a:off x="1320800" y="10251440"/>
+            <a:ext cx="7630160" cy="6723575"/>
           </a:xfrm>
           <a:prstGeom prst="rect">
             <a:avLst/>
@@ -7612,7 +7658,7 @@
           </a:bodyPr>
           <a:lstStyle/>
           <a:p>
-            <a:pPr marL="0" lvl="0" indent="0" algn="l" rtl="0">
+            <a:pPr marL="0" lvl="0" indent="0" rtl="0">
               <a:lnSpc>
                 <a:spcPct val="150000"/>
               </a:lnSpc>
@@ -7626,7 +7672,7 @@
               <a:buNone/>
             </a:pPr>
             <a:r>
-              <a:rPr lang="es-419" sz="2200" dirty="0">
+              <a:rPr lang="es-419" sz="2400" dirty="0">
                 <a:solidFill>
                   <a:schemeClr val="lt1"/>
                 </a:solidFill>
@@ -7638,7 +7684,7 @@
               <a:t>&lt;&lt;</a:t>
             </a:r>
             <a:r>
-              <a:rPr lang="es-419" sz="2200" dirty="0" err="1">
+              <a:rPr lang="es-419" sz="2400" dirty="0" err="1">
                 <a:solidFill>
                   <a:schemeClr val="lt1"/>
                 </a:solidFill>
@@ -7650,7 +7696,7 @@
               <a:t>abstracto_desc</a:t>
             </a:r>
             <a:r>
-              <a:rPr lang="es-419" sz="2200" dirty="0">
+              <a:rPr lang="es-419" sz="2400" dirty="0">
                 <a:solidFill>
                   <a:schemeClr val="lt1"/>
                 </a:solidFill>
@@ -7661,18 +7707,9 @@
               </a:rPr>
               <a:t>&gt;&gt;</a:t>
             </a:r>
-            <a:endParaRPr sz="2200" dirty="0">
-              <a:solidFill>
-                <a:schemeClr val="lt1"/>
-              </a:solidFill>
-              <a:latin typeface="Formular" panose="02000000000000000000" pitchFamily="2" charset="0"/>
-              <a:ea typeface="Public Sans"/>
-              <a:cs typeface="Public Sans"/>
-              <a:sym typeface="Public Sans"/>
-            </a:endParaRPr>
-          </a:p>
-          <a:p>
-            <a:pPr marL="0" lvl="0" indent="0" algn="l" rtl="0">
+          </a:p>
+          <a:p>
+            <a:pPr marL="0" lvl="0" indent="0" rtl="0">
               <a:lnSpc>
                 <a:spcPct val="150000"/>
               </a:lnSpc>
@@ -7685,7 +7722,7 @@
               <a:buSzPts val="853"/>
               <a:buNone/>
             </a:pPr>
-            <a:endParaRPr sz="1850" dirty="0">
+            <a:endParaRPr lang="es-419" sz="2400" dirty="0">
               <a:solidFill>
                 <a:schemeClr val="lt1"/>
               </a:solidFill>
@@ -7696,7 +7733,7 @@
             </a:endParaRPr>
           </a:p>
           <a:p>
-            <a:pPr marL="0" lvl="0" indent="0" algn="l" rtl="0">
+            <a:pPr marL="0" lvl="0" indent="0" rtl="0">
               <a:spcBef>
                 <a:spcPts val="0"/>
               </a:spcBef>
@@ -7706,7 +7743,7 @@
               <a:buSzPts val="853"/>
               <a:buNone/>
             </a:pPr>
-            <a:endParaRPr sz="1850" dirty="0">
+            <a:endParaRPr sz="2400" dirty="0">
               <a:solidFill>
                 <a:schemeClr val="lt1"/>
               </a:solidFill>

</xml_diff>

<commit_message>
cambio contraste portada reporte UTP
</commit_message>
<xml_diff>
--- a/assets/template_utp_alumnos.pptx
+++ b/assets/template_utp_alumnos.pptx
@@ -6506,10 +6506,11 @@
   <p:cSld>
     <p:bg>
       <p:bgPr>
-        <a:blipFill>
+        <a:blipFill dpi="0" rotWithShape="1">
           <a:blip r:embed="rId3">
-            <a:alphaModFix/>
+            <a:lum/>
           </a:blip>
+          <a:srcRect/>
           <a:stretch>
             <a:fillRect/>
           </a:stretch>

</xml_diff>